<commit_message>
Session 1 deck: drop workstreams and operational truth slides
Removes the seven workstreams slide and the "written up after the route"
slide, and drops the documents point from the AI process slide. The driver
reality point moves to the demo presenter notes so it can still be said out
loud without a slide.

Deck goes from 11 slides to 9.

Co-Authored-By: Claude Opus 5 (1M context) <noreply@anthropic.com>
</commit_message>
<xml_diff>
--- a/Presentation/Incident-Tracker-Launch-Session-1.pptx
+++ b/Presentation/Incident-Tracker-Launch-Session-1.pptx
@@ -14,8 +14,6 @@
     <p:sldId id="262" r:id="rId14"/>
     <p:sldId id="263" r:id="rId15"/>
     <p:sldId id="264" r:id="rId16"/>
-    <p:sldId id="265" r:id="rId17"/>
-    <p:sldId id="266" r:id="rId18"/>
   </p:sldIdLst>
   <p:sldSz cx="12191695" cy="6858000" type="screen4x3"/>
   <p:notesSz cx="6858000" cy="9144000"/>
@@ -537,146 +535,6 @@
 </p:notes>
 </file>
 
-<file path=ppt/notesSlides/notesSlide10.xml><?xml version="1.0" encoding="utf-8"?>
-<p:notes xmlns:a="http://schemas.openxmlformats.org/drawingml/2006/main" xmlns:p="http://schemas.openxmlformats.org/presentationml/2006/main" xmlns:r="http://schemas.openxmlformats.org/officeDocument/2006/relationships">
-  <p:cSld>
-    <p:spTree>
-      <p:nvGrpSpPr>
-        <p:cNvPr id="1" name=""/>
-        <p:cNvGrpSpPr/>
-        <p:nvPr/>
-      </p:nvGrpSpPr>
-      <p:grpSpPr>
-        <a:xfrm>
-          <a:off x="0" y="0"/>
-          <a:ext cx="0" cy="0"/>
-          <a:chOff x="0" y="0"/>
-          <a:chExt cx="0" cy="0"/>
-        </a:xfrm>
-      </p:grpSpPr>
-      <p:sp>
-        <p:nvSpPr>
-          <p:cNvPr id="2" name="Slide Image Placeholder 1"/>
-          <p:cNvSpPr>
-            <a:spLocks noGrp="1"/>
-          </p:cNvSpPr>
-          <p:nvPr>
-            <p:ph type="sldImg" idx="2"/>
-          </p:nvPr>
-        </p:nvSpPr>
-        <p:spPr/>
-      </p:sp>
-      <p:sp>
-        <p:nvSpPr>
-          <p:cNvPr id="3" name="Notes Placeholder 2"/>
-          <p:cNvSpPr>
-            <a:spLocks noGrp="1"/>
-          </p:cNvSpPr>
-          <p:nvPr>
-            <p:ph type="body" idx="3" sz="quarter"/>
-          </p:nvPr>
-        </p:nvSpPr>
-        <p:spPr/>
-        <p:txBody>
-          <a:bodyPr/>
-          <a:lstStyle/>
-          <a:p>
-            <a:r>
-              <a:t>Show incidents-vnext.staging.student-transportation.tylerapp.com briefly. Student names in this screenshot are blurred.</a:t>
-            </a:r>
-          </a:p>
-        </p:txBody>
-      </p:sp>
-      <p:sp>
-        <p:nvSpPr>
-          <p:cNvPr id="4" name="Slide Number Placeholder 3"/>
-          <p:cNvSpPr>
-            <a:spLocks noGrp="1"/>
-          </p:cNvSpPr>
-          <p:nvPr>
-            <p:ph type="sldNum" idx="5" sz="quarter"/>
-          </p:nvPr>
-        </p:nvSpPr>
-        <p:spPr/>
-      </p:sp>
-    </p:spTree>
-  </p:cSld>
-  <p:clrMapOvr>
-    <a:masterClrMapping/>
-  </p:clrMapOvr>
-</p:notes>
-</file>
-
-<file path=ppt/notesSlides/notesSlide11.xml><?xml version="1.0" encoding="utf-8"?>
-<p:notes xmlns:a="http://schemas.openxmlformats.org/drawingml/2006/main" xmlns:p="http://schemas.openxmlformats.org/presentationml/2006/main" xmlns:r="http://schemas.openxmlformats.org/officeDocument/2006/relationships">
-  <p:cSld>
-    <p:spTree>
-      <p:nvGrpSpPr>
-        <p:cNvPr id="1" name=""/>
-        <p:cNvGrpSpPr/>
-        <p:nvPr/>
-      </p:nvGrpSpPr>
-      <p:grpSpPr>
-        <a:xfrm>
-          <a:off x="0" y="0"/>
-          <a:ext cx="0" cy="0"/>
-          <a:chOff x="0" y="0"/>
-          <a:chExt cx="0" cy="0"/>
-        </a:xfrm>
-      </p:grpSpPr>
-      <p:sp>
-        <p:nvSpPr>
-          <p:cNvPr id="2" name="Slide Image Placeholder 1"/>
-          <p:cNvSpPr>
-            <a:spLocks noGrp="1"/>
-          </p:cNvSpPr>
-          <p:nvPr>
-            <p:ph type="sldImg" idx="2"/>
-          </p:nvPr>
-        </p:nvSpPr>
-        <p:spPr/>
-      </p:sp>
-      <p:sp>
-        <p:nvSpPr>
-          <p:cNvPr id="3" name="Notes Placeholder 2"/>
-          <p:cNvSpPr>
-            <a:spLocks noGrp="1"/>
-          </p:cNvSpPr>
-          <p:nvPr>
-            <p:ph type="body" idx="3" sz="quarter"/>
-          </p:nvPr>
-        </p:nvSpPr>
-        <p:spPr/>
-        <p:txBody>
-          <a:bodyPr/>
-          <a:lstStyle/>
-          <a:p>
-            <a:r>
-              <a:t>Going forward. From next Friday the board gets filtered by person and each owner gives status on their own items.</a:t>
-            </a:r>
-          </a:p>
-        </p:txBody>
-      </p:sp>
-      <p:sp>
-        <p:nvSpPr>
-          <p:cNvPr id="4" name="Slide Number Placeholder 3"/>
-          <p:cNvSpPr>
-            <a:spLocks noGrp="1"/>
-          </p:cNvSpPr>
-          <p:nvPr>
-            <p:ph type="sldNum" idx="5" sz="quarter"/>
-          </p:nvPr>
-        </p:nvSpPr>
-        <p:spPr/>
-      </p:sp>
-    </p:spTree>
-  </p:cSld>
-  <p:clrMapOvr>
-    <a:masterClrMapping/>
-  </p:clrMapOvr>
-</p:notes>
-</file>
-
 <file path=ppt/notesSlides/notesSlide2.xml><?xml version="1.0" encoding="utf-8"?>
 <p:notes xmlns:a="http://schemas.openxmlformats.org/drawingml/2006/main" xmlns:p="http://schemas.openxmlformats.org/presentationml/2006/main" xmlns:r="http://schemas.openxmlformats.org/officeDocument/2006/relationships">
   <p:cSld>
@@ -862,7 +720,7 @@
           <a:lstStyle/>
           <a:p>
             <a:r>
-              <a:t>Still BK: the shape of the plan. The workstreams are containers; the items inside them are what people own.</a:t>
+              <a:t>Background. The gap Incidents fills: clients on homegrown tools, the real conversation in email and never tied to the record.</a:t>
             </a:r>
           </a:p>
         </p:txBody>
@@ -932,7 +790,7 @@
           <a:lstStyle/>
           <a:p>
             <a:r>
-              <a:t>Background. The gap Incidents fills, and that the design is settled.</a:t>
+              <a:t>The process is part of what makes this project unusual: AI drove the design and the mockups. It began as a Figma Make design and moved to Claude mid-project, where Claude Code built the working Forge prototype. Say AI-powered, not hackathon.</a:t>
             </a:r>
           </a:p>
         </p:txBody>
@@ -1002,7 +860,7 @@
           <a:lstStyle/>
           <a:p>
             <a:r>
-              <a:t>The process is part of what makes this project unusual: AI drove the design, the mockups, and the documents. It began as a Figma Make design and moved to Claude mid-project, where Claude Code built the working Forge prototype. Say AI-powered, not hackathon.</a:t>
+              <a:t>The only system slide. Name the five capabilities, do not explain them here: the demo does that. Data is realistic but simulated, so no real notifications go out.</a:t>
             </a:r>
           </a:p>
         </p:txBody>
@@ -1072,7 +930,7 @@
           <a:lstStyle/>
           <a:p>
             <a:r>
-              <a:t>SAY THIS: an incident almost never gets written up while it is happening. The driver's job in the moment is to keep 50 kids safe and keep the bus moving. The report comes later, once they have pulled into the school loop or gotten back to the garage. Note we are not showing the driver tablet today.</a:t>
+              <a:t>Switch to captwildguns.github.io/incident-tracker. Five beats, about 15 minutes. This is where the detail lives now. Worth mentioning out loud: a driver files from a tablet after the route, not during it, and we are not showing the tablet today.</a:t>
             </a:r>
           </a:p>
         </p:txBody>
@@ -1142,7 +1000,7 @@
           <a:lstStyle/>
           <a:p>
             <a:r>
-              <a:t>The only system slide. Name the five capabilities, do not explain them here: the demo does that. Data is realistic but simulated, so no real notifications go out.</a:t>
+              <a:t>Show incidents-vnext.staging.student-transportation.tylerapp.com briefly. Student names in this screenshot are blurred.</a:t>
             </a:r>
           </a:p>
         </p:txBody>
@@ -1212,7 +1070,7 @@
           <a:lstStyle/>
           <a:p>
             <a:r>
-              <a:t>Switch to captwildguns.github.io/incident-tracker. Five beats, about 15 minutes. This is where the detail lives now.</a:t>
+              <a:t>Going forward. From next Friday the board gets filtered by person and each owner gives status on their own items.</a:t>
             </a:r>
           </a:p>
         </p:txBody>
@@ -4221,90 +4079,6 @@
       <p:pic>
         <p:nvPicPr>
           <p:cNvPr id="2" name="Picture 1" descr="01.png"/>
-          <p:cNvPicPr>
-            <a:picLocks noChangeAspect="1"/>
-          </p:cNvPicPr>
-          <p:nvPr/>
-        </p:nvPicPr>
-        <p:blipFill>
-          <a:blip r:embed="rId2"/>
-          <a:stretch>
-            <a:fillRect/>
-          </a:stretch>
-        </p:blipFill>
-        <p:spPr>
-          <a:xfrm>
-            <a:off x="0" y="0"/>
-            <a:ext cx="12191695" cy="6858000"/>
-          </a:xfrm>
-          <a:prstGeom prst="rect">
-            <a:avLst/>
-          </a:prstGeom>
-        </p:spPr>
-      </p:pic>
-    </p:spTree>
-  </p:cSld>
-  <p:clrMapOvr>
-    <a:masterClrMapping/>
-  </p:clrMapOvr>
-</p:sld>
-</file>
-
-<file path=ppt/slides/slide10.xml><?xml version="1.0" encoding="utf-8"?>
-<p:sld xmlns:a="http://schemas.openxmlformats.org/drawingml/2006/main" xmlns:p="http://schemas.openxmlformats.org/presentationml/2006/main" xmlns:r="http://schemas.openxmlformats.org/officeDocument/2006/relationships">
-  <p:cSld>
-    <p:spTree>
-      <p:nvGrpSpPr>
-        <p:cNvPr id="1" name=""/>
-        <p:cNvGrpSpPr/>
-        <p:nvPr/>
-      </p:nvGrpSpPr>
-      <p:grpSpPr/>
-      <p:pic>
-        <p:nvPicPr>
-          <p:cNvPr id="2" name="Picture 1" descr="10.png"/>
-          <p:cNvPicPr>
-            <a:picLocks noChangeAspect="1"/>
-          </p:cNvPicPr>
-          <p:nvPr/>
-        </p:nvPicPr>
-        <p:blipFill>
-          <a:blip r:embed="rId2"/>
-          <a:stretch>
-            <a:fillRect/>
-          </a:stretch>
-        </p:blipFill>
-        <p:spPr>
-          <a:xfrm>
-            <a:off x="0" y="0"/>
-            <a:ext cx="12191695" cy="6858000"/>
-          </a:xfrm>
-          <a:prstGeom prst="rect">
-            <a:avLst/>
-          </a:prstGeom>
-        </p:spPr>
-      </p:pic>
-    </p:spTree>
-  </p:cSld>
-  <p:clrMapOvr>
-    <a:masterClrMapping/>
-  </p:clrMapOvr>
-</p:sld>
-</file>
-
-<file path=ppt/slides/slide11.xml><?xml version="1.0" encoding="utf-8"?>
-<p:sld xmlns:a="http://schemas.openxmlformats.org/drawingml/2006/main" xmlns:p="http://schemas.openxmlformats.org/presentationml/2006/main" xmlns:r="http://schemas.openxmlformats.org/officeDocument/2006/relationships">
-  <p:cSld>
-    <p:spTree>
-      <p:nvGrpSpPr>
-        <p:cNvPr id="1" name=""/>
-        <p:cNvGrpSpPr/>
-        <p:nvPr/>
-      </p:nvGrpSpPr>
-      <p:grpSpPr/>
-      <p:pic>
-        <p:nvPicPr>
-          <p:cNvPr id="2" name="Picture 1" descr="11.png"/>
           <p:cNvPicPr>
             <a:picLocks noChangeAspect="1"/>
           </p:cNvPicPr>

</xml_diff>